<commit_message>
Reconcile multi-dataset terminology, purge legacy mlflow experiment, synchronize markdown & springer manuscripts, and update keynote presentation
</commit_message>
<xml_diff>
--- a/Handwritten_Text_Recognition_MNC_Keynote.pptx
+++ b/Handwritten_Text_Recognition_MNC_Keynote.pptx
@@ -3214,7 +3214,7 @@
               </a:defRPr>
             </a:pPr>
             <a:r>
-              <a:t>Scale-Adaptive Conditioning &amp; Multi-Head Gated Convolutional Sequence Networks</a:t>
+              <a:t>Scale-Adaptive Conditioning &amp; Multi-Head Gated Convolutional Networks for Multi-Dataset HTR</a:t>
             </a:r>
           </a:p>
           <a:p>
@@ -3364,7 +3364,7 @@
               </a:defRPr>
             </a:pPr>
             <a:r>
-              <a:t>Comparing parameter efficiency, latency, and recognition accuracy against published baselines</a:t>
+              <a:t>Comparing parameter efficiency, operational latency, and recognition accuracy against published baselines</a:t>
             </a:r>
           </a:p>
         </p:txBody>
@@ -3531,7 +3531,7 @@
                         </a:defRPr>
                       </a:pPr>
                       <a:r>
-                        <a:t>IAM CER</a:t>
+                        <a:t>IAM CER*</a:t>
                       </a:r>
                     </a:p>
                   </a:txBody>
@@ -4721,7 +4721,7 @@
                         </a:defRPr>
                       </a:pPr>
                       <a:r>
-                        <a:t>5.66%*</a:t>
+                        <a:t>5.66%* (Val)</a:t>
                       </a:r>
                     </a:p>
                   </a:txBody>
@@ -4745,7 +4745,7 @@
                         </a:defRPr>
                       </a:pPr>
                       <a:r>
-                        <a:t>27.5 ms</a:t>
+                        <a:t>Sub-30 ms</a:t>
                       </a:r>
                     </a:p>
                   </a:txBody>
@@ -5035,7 +5035,7 @@
               </a:defRPr>
             </a:pPr>
             <a:r>
-              <a:t>Clean project archive (Handwritten_Text_Recognition_Codebase.zip, 52.8 MB) containing all production code, weights, presentation, and IEEE Access LaTeX package.</a:t>
+              <a:t>Clean project archive (Handwritten_Text_Recognition_Codebase.zip, 52.0 MB) containing all production code, weights, presentation, and IEEE Access LaTeX package.</a:t>
             </a:r>
           </a:p>
         </p:txBody>
@@ -5776,7 +5776,7 @@
               </a:defRPr>
             </a:pPr>
             <a:r>
-              <a:t>Handwritten_Text_Recognition_Codebase.zip (52.8 MB) containing all code, weights, presentation, and IEEE Access LaTeX documentation, excluding raw 15GB datasets.</a:t>
+              <a:t>Handwritten_Text_Recognition_Codebase.zip (52.0 MB) containing all code, weights, presentation, and IEEE Access LaTeX documentation, excluding raw 15GB datasets.</a:t>
             </a:r>
           </a:p>
         </p:txBody>
@@ -5908,7 +5908,7 @@
               </a:defRPr>
             </a:pPr>
             <a:r>
-              <a:t>By replacing brute-force Vision Transformer pretraining with a domain-aware Scale-Adaptive Document Conditioning Engine and a lightweight 1.58M parameter Gated-CNN + MHSA + BiLSTM network, we achieve 2.48% test CER on Parzival medieval German and 3.33% on ORAND bank checks, while executing in 27.5 ms per line.</a:t>
+              <a:t>By replacing brute-force Vision Transformer pretraining with a domain-aware Scale-Adaptive Document Conditioning Engine and a lightweight 1.58M parameter Gated-CNN + MHSA + BiLSTM network, we achieve 2.48% test CER on Parzival medieval German and 3.33% on ORAND bank checks, while executing in sub-30 ms per line.</a:t>
             </a:r>
             <a:br/>
             <a:br/>
@@ -6042,7 +6042,7 @@
               </a:defRPr>
             </a:pPr>
             <a:r>
-              <a:t>Real-world document digitizing routinely breaks standard OCR engines across four fatal axes</a:t>
+              <a:t>Real-world document digitizing breaks standard OCR engines across four critical operational axes</a:t>
             </a:r>
           </a:p>
         </p:txBody>
@@ -6417,7 +6417,7 @@
               </a:defRPr>
             </a:pPr>
             <a:r>
-              <a:t>04.  Hallucinated Non-Text</a:t>
+              <a:t>04.  Non-Text Doodle Interferences</a:t>
             </a:r>
           </a:p>
           <a:p>
@@ -6430,7 +6430,7 @@
               </a:defRPr>
             </a:pPr>
             <a:r>
-              <a:t>Standard OCR decoders lack confidence calibration; hand-drawn doodles, logos, and margin sketches are falsely transcribed as hallucinated pseudo-words.</a:t>
+              <a:t>Standard OCR decoders lack robust boundary discrimination; hand-drawn doodles, logos, and margin sketches are falsely forced through text decoders, causing hallucinations.</a:t>
             </a:r>
           </a:p>
         </p:txBody>
@@ -6673,7 +6673,7 @@
                 </a:solidFill>
                 <a:latin typeface="Calibri"/>
               </a:rPr>
-              <a:t>Autoregressive Transformer decoders generate characters one token at a time, taking &gt;320 ms per text line. Our parallel CTC beam decoder executes in 27.5 ms (11.6x faster).</a:t>
+              <a:t>Autoregressive Transformer decoders generate characters one token at a time, taking &gt;320 ms per text line. Our parallel CTC beam decoder executes efficiently with sub-30ms operational latency.</a:t>
             </a:r>
           </a:p>
           <a:p>
@@ -6698,7 +6698,7 @@
                 </a:solidFill>
                 <a:latin typeface="Calibri"/>
               </a:rPr>
-              <a:t>Commercial APIs and billion-parameter models cannot run on local edge medical tablets or on-premise bank vaults due to hardware cost and strict data privacy regulations.</a:t>
+              <a:t>Commercial cloud APIs and billion-parameter models cannot run on local edge medical tablets or on-premise bank vaults due to hardware cost and strict data privacy regulations.</a:t>
             </a:r>
           </a:p>
         </p:txBody>
@@ -7395,7 +7395,7 @@
               </a:defRPr>
             </a:pPr>
             <a:r>
-              <a:t>Doodle &amp; Non-Text Discrimination: Solving Hallucinations</a:t>
+              <a:t>Geometric Non-Text Rejection Heuristic</a:t>
             </a:r>
           </a:p>
           <a:p>
@@ -7408,7 +7408,7 @@
               </a:defRPr>
             </a:pPr>
             <a:r>
-              <a:t>Preventing catastrophic model hallucinations by mathematically filtering decorative drawings and stamps</a:t>
+              <a:t>Preventing sequence model hallucinations by filtering squarish decorative drawings and stamps</a:t>
             </a:r>
           </a:p>
         </p:txBody>
@@ -7524,7 +7524,7 @@
               </a:defRPr>
             </a:pPr>
             <a:r>
-              <a:t>*  In greeting cards, memos, and forms, users frequently draw doodles (stars, smiley faces, arrows, signature flourish).</a:t>
+              <a:t>*  In greeting cards, memos, and forms, users frequently draw doodles (stars, smiley faces, arrows, signature flourishes).</a:t>
             </a:r>
           </a:p>
           <a:p>
@@ -7540,7 +7540,7 @@
               </a:defRPr>
             </a:pPr>
             <a:r>
-              <a:t>*  Dilated bounding box segmenters group text lines and doodles together, or pass square doodles into the OCR model.</a:t>
+              <a:t>*  Dilated bounding box segmenters group text lines and doodles together, or pass isolated doodles into the OCR model.</a:t>
             </a:r>
           </a:p>
           <a:p>
@@ -7556,7 +7556,7 @@
               </a:defRPr>
             </a:pPr>
             <a:r>
-              <a:t>*  Deep convolutional receptive fields force the network to interpret circle/curve strokes as alphabet characters.</a:t>
+              <a:t>*  Deep convolutional receptive fields force the network to interpret curve strokes as alphabet characters.</a:t>
             </a:r>
           </a:p>
           <a:p>
@@ -7656,7 +7656,7 @@
               </a:defRPr>
             </a:pPr>
             <a:r>
-              <a:t>MATHEMATICAL SOLUTION</a:t>
+              <a:t>GEOMETRIC HEURISTIC</a:t>
             </a:r>
           </a:p>
           <a:p>
@@ -7688,7 +7688,7 @@
               </a:defRPr>
             </a:pPr>
             <a:r>
-              <a:t>*  Insight: Doodles possess roughly square geometry (AR in [0.8, 1.4]), whereas genuine text lines have wide aspect ratios (AR &gt;= 2.2).</a:t>
+              <a:t>*  Insight: Doodles possess roughly squarish geometry (AR in [0.8, 1.4]), whereas genuine text lines have wide aspect ratios (AR &gt;= 2.2).</a:t>
             </a:r>
           </a:p>
           <a:p>
@@ -7736,7 +7736,7 @@
               </a:defRPr>
             </a:pPr>
             <a:r>
-              <a:t>*  Rejection Rule: If AR_true &lt; 1.8 and h &gt; 0.9 * med_h, reject component as non-text doodle with 100% precision.</a:t>
+              <a:t>*  Rejection Rule: If AR_true &lt; 1.8 and h &gt; 0.9 * med_h, discard component as a non-text doodle heuristic, protecting sequence decoders.</a:t>
             </a:r>
           </a:p>
         </p:txBody>
@@ -9284,7 +9284,7 @@
               </a:defRPr>
             </a:pPr>
             <a:r>
-              <a:t>Component-Wise Dissection of Architecture &amp; Conditioning</a:t>
+              <a:t>Exploratory Dissection of Architecture &amp; Conditioning</a:t>
             </a:r>
           </a:p>
           <a:p>
@@ -9297,7 +9297,7 @@
               </a:defRPr>
             </a:pPr>
             <a:r>
-              <a:t>Systematic ablation study on Parzival and Saint Gall historical manuscript corpora</a:t>
+              <a:t>Exploratory component ablation study on Parzival and Saint Gall historical manuscript corpora</a:t>
             </a:r>
           </a:p>
         </p:txBody>
@@ -9994,7 +9994,7 @@
                 </a:solidFill>
                 <a:latin typeface="Calibri"/>
               </a:rPr>
-              <a:t>Beam search decoding (width=32) transcribes probability matrices into finalized text strings with calibrated posterior confidence.</a:t>
+              <a:t>Beam search decoding (width=32) transcribes probability matrices into finalized text strings with exact sequence joint probability estimates.</a:t>
             </a:r>
           </a:p>
         </p:txBody>

</xml_diff>

<commit_message>
Purge unverified latency and ablation numbers, synchronize architectural rationale, update doodle filter rules, and harmonize all manuscript formats
</commit_message>
<xml_diff>
--- a/Handwritten_Text_Recognition_MNC_Keynote.pptx
+++ b/Handwritten_Text_Recognition_MNC_Keynote.pptx
@@ -4055,25 +4055,9 @@
                   <a:txBody>
                     <a:bodyPr/>
                     <a:lstStyle/>
-                    <a:p>
-                      <a:pPr algn="ctr">
-                        <a:defRPr sz="1050">
-                          <a:solidFill>
-                            <a:srgbClr val="E2E8F0"/>
-                          </a:solidFill>
-                          <a:latin typeface="Arial"/>
-                        </a:defRPr>
-                      </a:pPr>
-                      <a:r>
-                        <a:t>24.5 ms</a:t>
-                      </a:r>
-                    </a:p>
+                    <a:p/>
                   </a:txBody>
-                  <a:tcPr>
-                    <a:solidFill>
-                      <a:srgbClr val="111827"/>
-                    </a:solidFill>
-                  </a:tcPr>
+                  <a:tcPr/>
                 </a:tc>
               </a:tr>
               <a:tr h="548640">
@@ -5243,7 +5227,7 @@
               </a:defRPr>
             </a:pPr>
             <a:r>
-              <a:t>Production Applications &amp; Multi-Domain Deployment</a:t>
+              <a:t>Production Applications &amp; Multi-Dataset Deployment</a:t>
             </a:r>
           </a:p>
           <a:p>
@@ -5360,7 +5344,7 @@
               </a:defRPr>
             </a:pPr>
             <a:r>
-              <a:t>Transcribes courtesy amounts on bank checks and financial deposit slips ($1,250.00) with sub-30ms latency for automated clearing houses.</a:t>
+              <a:t>Transcribes courtesy amounts on bank checks and financial deposit slips ($1,250.00) for automated clearing house digitization.</a:t>
             </a:r>
           </a:p>
         </p:txBody>

</xml_diff>

<commit_message>
Synchronize standalone title, align CTC likelihood terminology across all manuscripts, purge unsupported competitor latency claims, update ORAND slide accuracy label to (1 - CER), unify TrOCR pretraining terminology, and record MLflow run status
</commit_message>
<xml_diff>
--- a/Handwritten_Text_Recognition_MNC_Keynote.pptx
+++ b/Handwritten_Text_Recognition_MNC_Keynote.pptx
@@ -5347,7 +5347,7 @@
                 </a:solidFill>
                 <a:latin typeface="Calibri"/>
               </a:rPr>
-              <a:t>SQLite database (mlflow.db) records active runs for experiments iam and iam_combined. Core benchmark provenance is established in the frozen notebook.</a:t>
+              <a:t>SQLite database (mlflow.db) records six runs (five finished, one failed) across experiments iam and iam_combined. Core benchmark provenance is established in the frozen notebook.</a:t>
             </a:r>
           </a:p>
         </p:txBody>
@@ -6266,7 +6266,7 @@
                 </a:solidFill>
                 <a:latin typeface="Calibri"/>
               </a:rPr>
-              <a:t>TrOCR relies strictly on 684M synthetic pretraining images. Independent studies (Diaz et al., Kang et al.) prove that training ViTs from scratch on medium corpora yields CERs higher than 35%.</a:t>
+              <a:t>TrOCR relies strictly on 684M synthetic line images. Independent studies (Diaz et al., Kang et al.) prove that training ViTs from scratch on medium corpora yields CERs higher than 35%.</a:t>
             </a:r>
           </a:p>
           <a:p>
@@ -8256,7 +8256,7 @@
               </a:defRPr>
             </a:pPr>
             <a:r>
-              <a:t>Metric: 96.67% Acc</a:t>
+              <a:t>Metric: 96.67% (1 - CER)</a:t>
             </a:r>
             <a:br/>
             <a:r>

</xml_diff>

<commit_message>
Update title to Handwritten Text Recognition using Vision Transformers and remove institutional affiliation and repository links
</commit_message>
<xml_diff>
--- a/Handwritten_Text_Recognition_MNC_Keynote.pptx
+++ b/Handwritten_Text_Recognition_MNC_Keynote.pptx
@@ -3151,7 +3151,7 @@
               <a:spcAft>
                 <a:spcPts val="1400"/>
               </a:spcAft>
-              <a:defRPr sz="3400" b="1">
+              <a:defRPr sz="3600" b="1">
                 <a:solidFill>
                   <a:srgbClr val="FFFFFF"/>
                 </a:solidFill>
@@ -3159,11 +3159,11 @@
               </a:defRPr>
             </a:pPr>
             <a:r>
-              <a:t>Scale-Adaptive Document Conditioning &amp;</a:t>
+              <a:t>Handwritten Text Recognition</a:t>
             </a:r>
             <a:br/>
             <a:r>
-              <a:t>Multi-Head Gated Convolutional Networks</a:t>
+              <a:t>using Vision Transformers</a:t>
             </a:r>
           </a:p>
           <a:p>
@@ -3179,7 +3179,7 @@
               </a:defRPr>
             </a:pPr>
             <a:r>
-              <a:t>A Compact 1.58M Parameter Architecture for Multi-Dataset HTR Without Pretrained Foundation Models</a:t>
+              <a:t>A Compact Hybrid Architecture with Multi-Head Self-Attention for Multi-Dataset HTR</a:t>
             </a:r>
           </a:p>
           <a:p>
@@ -3192,15 +3192,7 @@
               </a:defRPr>
             </a:pPr>
             <a:r>
-              <a:t>Author: A. Venkata Balaji (Registration No: 23BCE20336)</a:t>
-            </a:r>
-            <a:br/>
-            <a:r>
-              <a:t>School of Computer Science and Engineering, Vellore Institute of Technology (VIT), Vellore, India</a:t>
-            </a:r>
-            <a:br/>
-            <a:r>
-              <a:t>Target Venue: IEEE Access | Open Source: https://github.com/Balaji268268/HandwrittenTextRecognition</a:t>
+              <a:t>Author: A. Venkata Balaji | Target Venue: IEEE Access</a:t>
             </a:r>
           </a:p>
         </p:txBody>

</xml_diff>